<commit_message>
fix: presentazione e inserzioni con la fattura senza SdI
Rifatte dai sorgenti corretti: la presentazione (pptx e PDF, anche la slide
di riepilogo) e le grafiche della fattura in tre formati.

Co-Authored-By: Claude Opus 5.5 <noreply@anthropic.com>
Claude-Session: https://claude.ai/code/session_019omCPMHgUWhFNUA2V3e92d
</commit_message>
<xml_diff>
--- a/brand/presentazione/DottorCloud.pptx
+++ b/brand/presentazione/DottorCloud.pptx
@@ -871,7 +871,7 @@
           <a:p>
             <a:r>
               <a:rPr lang="en-US" dirty="0"/>
-              <a:t>Risponde a "gestisce la fatturazione?". Sì: dalla visita svolta nasce la fattura elettronica, che va allo SdI e al Sistema TS. La segreteria vede anche le visite svolte e non ancora fatturate.</a:t>
+              <a:t>Risponde a "gestisce la fatturazione?". Sì: dalla visita svolta nasce la fattura. Al paziente va in PDF e le spese al Sistema TS, perché per legge una prestazione sanitaria a una persona non passa dallo SdI; ad aziende ed enti va elettronica allo SdI. La segreteria vede anche le visite svolte e non ancora fatturate.</a:t>
             </a:r>
             <a:endParaRPr lang="en-US" dirty="0"/>
           </a:p>
@@ -5036,7 +5036,7 @@
                 <a:ea typeface="Calibri" pitchFamily="34" charset="-122"/>
                 <a:cs typeface="Calibri" pitchFamily="34" charset="-120"/>
               </a:rPr>
-              <a:t>Elettronica, allo SdI e al Sistema TS, senza ricopiare niente.</a:t>
+              <a:t>Al paziente in PDF, le spese al Sistema TS, allo SdI quando va.</a:t>
             </a:r>
             <a:endParaRPr lang="en-US" sz="1400" dirty="0"/>
           </a:p>
@@ -5288,7 +5288,7 @@
                 <a:ea typeface="Calibri" pitchFamily="34" charset="-122"/>
                 <a:cs typeface="Calibri" pitchFamily="34" charset="-120"/>
               </a:rPr>
-              <a:t>Invio e ricevute di consegna nel gestionale</a:t>
+              <a:t>Per aziende ed enti, con le ricevute nel gestionale</a:t>
             </a:r>
             <a:endParaRPr lang="en-US" sz="1200" dirty="0"/>
           </a:p>
@@ -8909,7 +8909,7 @@
                 <a:ea typeface="Calibri" pitchFamily="34" charset="-122"/>
                 <a:cs typeface="Calibri" pitchFamily="34" charset="-120"/>
               </a:rPr>
-              <a:t>Elettronica, SdI e Sistema TS</a:t>
+              <a:t>Sistema TS, SdI e PDF al paziente</a:t>
             </a:r>
             <a:endParaRPr lang="en-US" sz="1250" dirty="0"/>
           </a:p>

</xml_diff>